<commit_message>
more pics added to slides
</commit_message>
<xml_diff>
--- a/chapter 16.pptx
+++ b/chapter 16.pptx
@@ -5,10 +5,10 @@
     <p:sldMasterId id="2147483648" r:id="rId1"/>
   </p:sldMasterIdLst>
   <p:notesMasterIdLst>
-    <p:notesMasterId r:id="rId20"/>
+    <p:notesMasterId r:id="rId21"/>
   </p:notesMasterIdLst>
   <p:handoutMasterIdLst>
-    <p:handoutMasterId r:id="rId21"/>
+    <p:handoutMasterId r:id="rId22"/>
   </p:handoutMasterIdLst>
   <p:sldIdLst>
     <p:sldId id="259" r:id="rId2"/>
@@ -28,7 +28,8 @@
     <p:sldId id="277" r:id="rId16"/>
     <p:sldId id="278" r:id="rId17"/>
     <p:sldId id="281" r:id="rId18"/>
-    <p:sldId id="283" r:id="rId19"/>
+    <p:sldId id="285" r:id="rId19"/>
+    <p:sldId id="283" r:id="rId20"/>
   </p:sldIdLst>
   <p:sldSz cx="12192000" cy="6858000"/>
   <p:notesSz cx="6858000" cy="9144000"/>
@@ -4549,20 +4550,56 @@
           <a:chExt cx="0" cy="0"/>
         </a:xfrm>
       </p:grpSpPr>
-      <p:sp>
-        <p:nvSpPr>
-          <p:cNvPr id="2" name="Content Placeholder 1">
-            <a:extLst>
-              <a:ext uri="{FF2B5EF4-FFF2-40B4-BE49-F238E27FC236}">
-                <a16:creationId xmlns:a16="http://schemas.microsoft.com/office/drawing/2014/main" id="{48918A94-F3EA-F444-F9C2-467A9BA0DE8D}"/>
-              </a:ext>
-            </a:extLst>
-          </p:cNvPr>
-          <p:cNvSpPr>
-            <a:spLocks noGrp="1"/>
-          </p:cNvSpPr>
-          <p:nvPr>
-            <p:ph sz="half" idx="2"/>
+      <p:pic>
+        <p:nvPicPr>
+          <p:cNvPr id="7" name="Picture Placeholder 6">
+            <a:extLst>
+              <a:ext uri="{FF2B5EF4-FFF2-40B4-BE49-F238E27FC236}">
+                <a16:creationId xmlns:a16="http://schemas.microsoft.com/office/drawing/2014/main" id="{C29930BA-5120-4D98-A867-FFA215630989}"/>
+              </a:ext>
+            </a:extLst>
+          </p:cNvPr>
+          <p:cNvPicPr>
+            <a:picLocks noGrp="1" noChangeAspect="1"/>
+          </p:cNvPicPr>
+          <p:nvPr>
+            <p:ph type="pic" sz="quarter" idx="11"/>
+          </p:nvPr>
+        </p:nvPicPr>
+        <p:blipFill>
+          <a:blip r:embed="rId2">
+            <a:extLst>
+              <a:ext uri="{28A0092B-C50C-407E-A947-70E740481C1C}">
+                <a14:useLocalDpi xmlns:a14="http://schemas.microsoft.com/office/drawing/2010/main" val="0"/>
+              </a:ext>
+            </a:extLst>
+          </a:blip>
+          <a:srcRect t="13836" b="6736"/>
+          <a:stretch>
+            <a:fillRect/>
+          </a:stretch>
+        </p:blipFill>
+        <p:spPr>
+          <a:xfrm>
+            <a:off x="1619250" y="794952"/>
+            <a:ext cx="8953500" cy="4613661"/>
+          </a:xfrm>
+        </p:spPr>
+      </p:pic>
+      <p:sp>
+        <p:nvSpPr>
+          <p:cNvPr id="3" name="Text Placeholder 2">
+            <a:extLst>
+              <a:ext uri="{FF2B5EF4-FFF2-40B4-BE49-F238E27FC236}">
+                <a16:creationId xmlns:a16="http://schemas.microsoft.com/office/drawing/2014/main" id="{81F9A638-5C7C-1751-D7D7-99199CDEB544}"/>
+              </a:ext>
+            </a:extLst>
+          </p:cNvPr>
+          <p:cNvSpPr>
+            <a:spLocks noGrp="1"/>
+          </p:cNvSpPr>
+          <p:nvPr>
+            <p:ph type="body" sz="quarter" idx="12"/>
           </p:nvPr>
         </p:nvSpPr>
         <p:spPr/>
@@ -4572,92 +4609,37 @@
           <a:p>
             <a:r>
               <a:rPr lang="en-US" dirty="0"/>
-              <a:t>Hardware virtualization allows for the creation of several virtual machines that share the same physical machine.</a:t>
-            </a:r>
-          </a:p>
-          <a:p>
-            <a:pPr lvl="1"/>
-            <a:r>
-              <a:rPr lang="en-US" dirty="0"/>
-              <a:t>So, the resources a physical machine can be shared among several VMs.</a:t>
-            </a:r>
-          </a:p>
-          <a:p>
-            <a:r>
-              <a:rPr lang="en-US" dirty="0"/>
-              <a:t>A VM image is the set of bits that are loaded into a VM to enable its execution.</a:t>
-            </a:r>
-          </a:p>
-          <a:p>
-            <a:pPr lvl="1"/>
-            <a:r>
-              <a:rPr lang="en-US" dirty="0"/>
-              <a:t>VM images can be created by various techniques for provisioning, including using operating system functions or loading a pre-created image.</a:t>
-            </a:r>
-          </a:p>
-          <a:p>
-            <a:r>
-              <a:rPr lang="en-US" dirty="0"/>
-              <a:t>Containers are a packaging mechanism that virtualizes the operating system.</a:t>
-            </a:r>
-          </a:p>
-          <a:p>
-            <a:pPr lvl="1"/>
-            <a:r>
-              <a:rPr lang="en-US" dirty="0"/>
-              <a:t>A container can be moved from one environment to another if a compatible container runtime engine is available. </a:t>
-            </a:r>
-          </a:p>
-          <a:p>
-            <a:r>
-              <a:rPr lang="en-US" dirty="0"/>
-              <a:t>Placing several containers into a Pod means that they are all allocated together and any communication between the containers can be done quickly.</a:t>
-            </a:r>
-          </a:p>
-        </p:txBody>
-      </p:sp>
-      <p:sp>
-        <p:nvSpPr>
-          <p:cNvPr id="3" name="Title 2">
-            <a:extLst>
-              <a:ext uri="{FF2B5EF4-FFF2-40B4-BE49-F238E27FC236}">
-                <a16:creationId xmlns:a16="http://schemas.microsoft.com/office/drawing/2014/main" id="{2E12D28B-FF95-16C3-680F-E9E5F8E9CB02}"/>
-              </a:ext>
-            </a:extLst>
-          </p:cNvPr>
-          <p:cNvSpPr>
-            <a:spLocks noGrp="1"/>
-          </p:cNvSpPr>
-          <p:nvPr>
-            <p:ph type="title"/>
-          </p:nvPr>
-        </p:nvSpPr>
-        <p:spPr/>
-        <p:txBody>
-          <a:bodyPr/>
-          <a:lstStyle/>
-          <a:p>
-            <a:r>
-              <a:rPr lang="en-US" dirty="0"/>
-              <a:t>Summary</a:t>
-            </a:r>
-          </a:p>
-        </p:txBody>
-      </p:sp>
-      <p:sp>
-        <p:nvSpPr>
-          <p:cNvPr id="4" name="Slide Number Placeholder 3">
-            <a:extLst>
-              <a:ext uri="{FF2B5EF4-FFF2-40B4-BE49-F238E27FC236}">
-                <a16:creationId xmlns:a16="http://schemas.microsoft.com/office/drawing/2014/main" id="{1C7C89D6-8101-6BA3-F802-7C4683DACCC7}"/>
-              </a:ext>
-            </a:extLst>
-          </p:cNvPr>
-          <p:cNvSpPr>
-            <a:spLocks noGrp="1"/>
-          </p:cNvSpPr>
-          <p:nvPr>
-            <p:ph type="sldNum" sz="quarter" idx="10"/>
+              <a:t>A </a:t>
+            </a:r>
+            <a:r>
+              <a:rPr lang="en-US" dirty="0">
+                <a:solidFill>
+                  <a:schemeClr val="accent1"/>
+                </a:solidFill>
+              </a:rPr>
+              <a:t>Pod</a:t>
+            </a:r>
+            <a:r>
+              <a:rPr lang="en-US" dirty="0"/>
+              <a:t> is a group of related containers.</a:t>
+            </a:r>
+          </a:p>
+        </p:txBody>
+      </p:sp>
+      <p:sp>
+        <p:nvSpPr>
+          <p:cNvPr id="5" name="Slide Number Placeholder 4">
+            <a:extLst>
+              <a:ext uri="{FF2B5EF4-FFF2-40B4-BE49-F238E27FC236}">
+                <a16:creationId xmlns:a16="http://schemas.microsoft.com/office/drawing/2014/main" id="{97962A91-E7F7-DA5F-0F6A-30BBDD09F25B}"/>
+              </a:ext>
+            </a:extLst>
+          </p:cNvPr>
+          <p:cNvSpPr>
+            <a:spLocks noGrp="1"/>
+          </p:cNvSpPr>
+          <p:nvPr>
+            <p:ph type="sldNum" sz="quarter" idx="13"/>
           </p:nvPr>
         </p:nvSpPr>
         <p:spPr/>
@@ -4669,6 +4651,161 @@
               <a:rPr lang="en-US" smtClean="0"/>
               <a:pPr/>
               <a:t>18</a:t>
+            </a:fld>
+            <a:endParaRPr lang="en-US" dirty="0"/>
+          </a:p>
+        </p:txBody>
+      </p:sp>
+    </p:spTree>
+    <p:extLst>
+      <p:ext uri="{BB962C8B-B14F-4D97-AF65-F5344CB8AC3E}">
+        <p14:creationId xmlns:p14="http://schemas.microsoft.com/office/powerpoint/2010/main" val="443049845"/>
+      </p:ext>
+    </p:extLst>
+  </p:cSld>
+  <p:clrMapOvr>
+    <a:masterClrMapping/>
+  </p:clrMapOvr>
+</p:sld>
+</file>
+
+<file path=ppt/slides/slide19.xml><?xml version="1.0" encoding="utf-8"?>
+<p:sld xmlns:a="http://schemas.openxmlformats.org/drawingml/2006/main" xmlns:r="http://schemas.openxmlformats.org/officeDocument/2006/relationships" xmlns:p="http://schemas.openxmlformats.org/presentationml/2006/main">
+  <p:cSld>
+    <p:spTree>
+      <p:nvGrpSpPr>
+        <p:cNvPr id="1" name=""/>
+        <p:cNvGrpSpPr/>
+        <p:nvPr/>
+      </p:nvGrpSpPr>
+      <p:grpSpPr>
+        <a:xfrm>
+          <a:off x="0" y="0"/>
+          <a:ext cx="0" cy="0"/>
+          <a:chOff x="0" y="0"/>
+          <a:chExt cx="0" cy="0"/>
+        </a:xfrm>
+      </p:grpSpPr>
+      <p:sp>
+        <p:nvSpPr>
+          <p:cNvPr id="2" name="Content Placeholder 1">
+            <a:extLst>
+              <a:ext uri="{FF2B5EF4-FFF2-40B4-BE49-F238E27FC236}">
+                <a16:creationId xmlns:a16="http://schemas.microsoft.com/office/drawing/2014/main" id="{48918A94-F3EA-F444-F9C2-467A9BA0DE8D}"/>
+              </a:ext>
+            </a:extLst>
+          </p:cNvPr>
+          <p:cNvSpPr>
+            <a:spLocks noGrp="1"/>
+          </p:cNvSpPr>
+          <p:nvPr>
+            <p:ph sz="half" idx="2"/>
+          </p:nvPr>
+        </p:nvSpPr>
+        <p:spPr/>
+        <p:txBody>
+          <a:bodyPr/>
+          <a:lstStyle/>
+          <a:p>
+            <a:r>
+              <a:rPr lang="en-US" dirty="0"/>
+              <a:t>Hardware virtualization allows for the creation of several virtual machines that share the same physical machine.</a:t>
+            </a:r>
+          </a:p>
+          <a:p>
+            <a:pPr lvl="1"/>
+            <a:r>
+              <a:rPr lang="en-US" dirty="0"/>
+              <a:t>So, the resources a physical machine can be shared among several VMs.</a:t>
+            </a:r>
+          </a:p>
+          <a:p>
+            <a:r>
+              <a:rPr lang="en-US" dirty="0"/>
+              <a:t>A VM image is the set of bits that are loaded into a VM to enable its execution.</a:t>
+            </a:r>
+          </a:p>
+          <a:p>
+            <a:pPr lvl="1"/>
+            <a:r>
+              <a:rPr lang="en-US" dirty="0"/>
+              <a:t>VM images can be created by various techniques for provisioning, including using operating system functions or loading a pre-created image.</a:t>
+            </a:r>
+          </a:p>
+          <a:p>
+            <a:r>
+              <a:rPr lang="en-US" dirty="0"/>
+              <a:t>Containers are a packaging mechanism that virtualizes the operating system.</a:t>
+            </a:r>
+          </a:p>
+          <a:p>
+            <a:pPr lvl="1"/>
+            <a:r>
+              <a:rPr lang="en-US" dirty="0"/>
+              <a:t>A container can be moved from one environment to another if a compatible container runtime engine is available. </a:t>
+            </a:r>
+          </a:p>
+          <a:p>
+            <a:r>
+              <a:rPr lang="en-US" dirty="0"/>
+              <a:t>Placing several containers into a Pod means that they are all allocated together and any communication between the containers can be done quickly.</a:t>
+            </a:r>
+          </a:p>
+        </p:txBody>
+      </p:sp>
+      <p:sp>
+        <p:nvSpPr>
+          <p:cNvPr id="3" name="Title 2">
+            <a:extLst>
+              <a:ext uri="{FF2B5EF4-FFF2-40B4-BE49-F238E27FC236}">
+                <a16:creationId xmlns:a16="http://schemas.microsoft.com/office/drawing/2014/main" id="{2E12D28B-FF95-16C3-680F-E9E5F8E9CB02}"/>
+              </a:ext>
+            </a:extLst>
+          </p:cNvPr>
+          <p:cNvSpPr>
+            <a:spLocks noGrp="1"/>
+          </p:cNvSpPr>
+          <p:nvPr>
+            <p:ph type="title"/>
+          </p:nvPr>
+        </p:nvSpPr>
+        <p:spPr/>
+        <p:txBody>
+          <a:bodyPr/>
+          <a:lstStyle/>
+          <a:p>
+            <a:r>
+              <a:rPr lang="en-US" dirty="0"/>
+              <a:t>Summary</a:t>
+            </a:r>
+          </a:p>
+        </p:txBody>
+      </p:sp>
+      <p:sp>
+        <p:nvSpPr>
+          <p:cNvPr id="4" name="Slide Number Placeholder 3">
+            <a:extLst>
+              <a:ext uri="{FF2B5EF4-FFF2-40B4-BE49-F238E27FC236}">
+                <a16:creationId xmlns:a16="http://schemas.microsoft.com/office/drawing/2014/main" id="{1C7C89D6-8101-6BA3-F802-7C4683DACCC7}"/>
+              </a:ext>
+            </a:extLst>
+          </p:cNvPr>
+          <p:cNvSpPr>
+            <a:spLocks noGrp="1"/>
+          </p:cNvSpPr>
+          <p:nvPr>
+            <p:ph type="sldNum" sz="quarter" idx="10"/>
+          </p:nvPr>
+        </p:nvSpPr>
+        <p:spPr/>
+        <p:txBody>
+          <a:bodyPr/>
+          <a:lstStyle/>
+          <a:p>
+            <a:fld id="{AE311D09-C3D9-45E8-99CE-78E12234EEAD}" type="slidenum">
+              <a:rPr lang="en-US" smtClean="0"/>
+              <a:pPr/>
+              <a:t>19</a:t>
             </a:fld>
             <a:endParaRPr lang="en-US" dirty="0"/>
           </a:p>

</xml_diff>